<commit_message>
Update dashboard screenshots and presentation
Restyled Power BI report: page 1 retitled "The Daily Grind Sales
Dashboard" with a blue category chart. Presentation updated to match.

Co-Authored-By: Claude Opus 5 <noreply@anthropic.com>
</commit_message>
<xml_diff>
--- a/Pricing-Analysis-2023-2025.pptx
+++ b/Pricing-Analysis-2023-2025.pptx
@@ -325,7 +325,7 @@
           <a:p>
             <a:fld id="{80D97446-0BC7-4A66-B662-A168F6AE78B0}" type="datetimeFigureOut">
               <a:rPr lang="ru-KZ" smtClean="0"/>
-              <a:t>15.09.2026</a:t>
+              <a:t>16.09.2026</a:t>
             </a:fld>
             <a:endParaRPr lang="ru-KZ"/>
           </a:p>
@@ -855,7 +855,7 @@
           <a:p>
             <a:fld id="{80D97446-0BC7-4A66-B662-A168F6AE78B0}" type="datetimeFigureOut">
               <a:rPr lang="ru-KZ" smtClean="0"/>
-              <a:t>15.09.2026</a:t>
+              <a:t>16.09.2026</a:t>
             </a:fld>
             <a:endParaRPr lang="ru-KZ"/>
           </a:p>
@@ -1411,7 +1411,7 @@
           <a:p>
             <a:fld id="{80D97446-0BC7-4A66-B662-A168F6AE78B0}" type="datetimeFigureOut">
               <a:rPr lang="ru-KZ" smtClean="0"/>
-              <a:t>15.09.2026</a:t>
+              <a:t>16.09.2026</a:t>
             </a:fld>
             <a:endParaRPr lang="ru-KZ"/>
           </a:p>
@@ -1884,7 +1884,7 @@
           <a:p>
             <a:fld id="{80D97446-0BC7-4A66-B662-A168F6AE78B0}" type="datetimeFigureOut">
               <a:rPr lang="ru-KZ" smtClean="0"/>
-              <a:t>15.09.2026</a:t>
+              <a:t>16.09.2026</a:t>
             </a:fld>
             <a:endParaRPr lang="ru-KZ"/>
           </a:p>
@@ -2528,7 +2528,7 @@
           <a:p>
             <a:fld id="{80D97446-0BC7-4A66-B662-A168F6AE78B0}" type="datetimeFigureOut">
               <a:rPr lang="ru-KZ" smtClean="0"/>
-              <a:t>15.09.2026</a:t>
+              <a:t>16.09.2026</a:t>
             </a:fld>
             <a:endParaRPr lang="ru-KZ"/>
           </a:p>
@@ -2997,7 +2997,7 @@
           <a:p>
             <a:fld id="{80D97446-0BC7-4A66-B662-A168F6AE78B0}" type="datetimeFigureOut">
               <a:rPr lang="ru-KZ" smtClean="0"/>
-              <a:t>15.09.2026</a:t>
+              <a:t>16.09.2026</a:t>
             </a:fld>
             <a:endParaRPr lang="ru-KZ"/>
           </a:p>
@@ -3566,7 +3566,7 @@
           <a:p>
             <a:fld id="{80D97446-0BC7-4A66-B662-A168F6AE78B0}" type="datetimeFigureOut">
               <a:rPr lang="ru-KZ" smtClean="0"/>
-              <a:t>15.09.2026</a:t>
+              <a:t>16.09.2026</a:t>
             </a:fld>
             <a:endParaRPr lang="ru-KZ"/>
           </a:p>
@@ -4041,7 +4041,7 @@
           <a:p>
             <a:fld id="{80D97446-0BC7-4A66-B662-A168F6AE78B0}" type="datetimeFigureOut">
               <a:rPr lang="ru-KZ" smtClean="0"/>
-              <a:t>15.09.2026</a:t>
+              <a:t>16.09.2026</a:t>
             </a:fld>
             <a:endParaRPr lang="ru-KZ"/>
           </a:p>
@@ -4456,7 +4456,7 @@
           <a:p>
             <a:fld id="{80D97446-0BC7-4A66-B662-A168F6AE78B0}" type="datetimeFigureOut">
               <a:rPr lang="ru-KZ" smtClean="0"/>
-              <a:t>15.09.2026</a:t>
+              <a:t>16.09.2026</a:t>
             </a:fld>
             <a:endParaRPr lang="ru-KZ"/>
           </a:p>
@@ -4880,7 +4880,7 @@
           <a:p>
             <a:fld id="{80D97446-0BC7-4A66-B662-A168F6AE78B0}" type="datetimeFigureOut">
               <a:rPr lang="ru-KZ" smtClean="0"/>
-              <a:t>15.09.2026</a:t>
+              <a:t>16.09.2026</a:t>
             </a:fld>
             <a:endParaRPr lang="ru-KZ"/>
           </a:p>
@@ -5242,7 +5242,7 @@
           <a:p>
             <a:fld id="{80D97446-0BC7-4A66-B662-A168F6AE78B0}" type="datetimeFigureOut">
               <a:rPr lang="ru-KZ" smtClean="0"/>
-              <a:t>15.09.2026</a:t>
+              <a:t>16.09.2026</a:t>
             </a:fld>
             <a:endParaRPr lang="ru-KZ"/>
           </a:p>
@@ -5650,7 +5650,7 @@
           <a:p>
             <a:fld id="{80D97446-0BC7-4A66-B662-A168F6AE78B0}" type="datetimeFigureOut">
               <a:rPr lang="ru-KZ" smtClean="0"/>
-              <a:t>15.09.2026</a:t>
+              <a:t>16.09.2026</a:t>
             </a:fld>
             <a:endParaRPr lang="ru-KZ"/>
           </a:p>
@@ -6001,7 +6001,7 @@
           <a:p>
             <a:fld id="{80D97446-0BC7-4A66-B662-A168F6AE78B0}" type="datetimeFigureOut">
               <a:rPr lang="ru-KZ" smtClean="0"/>
-              <a:t>15.09.2026</a:t>
+              <a:t>16.09.2026</a:t>
             </a:fld>
             <a:endParaRPr lang="ru-KZ"/>
           </a:p>
@@ -6365,7 +6365,7 @@
           <a:p>
             <a:fld id="{80D97446-0BC7-4A66-B662-A168F6AE78B0}" type="datetimeFigureOut">
               <a:rPr lang="ru-KZ" smtClean="0"/>
-              <a:t>15.09.2026</a:t>
+              <a:t>16.09.2026</a:t>
             </a:fld>
             <a:endParaRPr lang="ru-KZ"/>
           </a:p>
@@ -6790,7 +6790,7 @@
           <a:p>
             <a:fld id="{80D97446-0BC7-4A66-B662-A168F6AE78B0}" type="datetimeFigureOut">
               <a:rPr lang="ru-KZ" smtClean="0"/>
-              <a:t>15.09.2026</a:t>
+              <a:t>16.09.2026</a:t>
             </a:fld>
             <a:endParaRPr lang="ru-KZ"/>
           </a:p>
@@ -7373,7 +7373,7 @@
           <a:p>
             <a:fld id="{80D97446-0BC7-4A66-B662-A168F6AE78B0}" type="datetimeFigureOut">
               <a:rPr lang="ru-KZ" smtClean="0"/>
-              <a:t>15.09.2026</a:t>
+              <a:t>16.09.2026</a:t>
             </a:fld>
             <a:endParaRPr lang="ru-KZ"/>
           </a:p>
@@ -7675,7 +7675,7 @@
           <a:p>
             <a:fld id="{80D97446-0BC7-4A66-B662-A168F6AE78B0}" type="datetimeFigureOut">
               <a:rPr lang="ru-KZ" smtClean="0"/>
-              <a:t>15.09.2026</a:t>
+              <a:t>16.09.2026</a:t>
             </a:fld>
             <a:endParaRPr lang="ru-KZ"/>
           </a:p>
@@ -7927,7 +7927,7 @@
           <a:p>
             <a:fld id="{80D97446-0BC7-4A66-B662-A168F6AE78B0}" type="datetimeFigureOut">
               <a:rPr lang="ru-KZ" smtClean="0"/>
-              <a:t>15.09.2026</a:t>
+              <a:t>16.09.2026</a:t>
             </a:fld>
             <a:endParaRPr lang="ru-KZ"/>
           </a:p>
@@ -8239,7 +8239,7 @@
           <a:p>
             <a:fld id="{80D97446-0BC7-4A66-B662-A168F6AE78B0}" type="datetimeFigureOut">
               <a:rPr lang="ru-KZ" smtClean="0"/>
-              <a:t>15.09.2026</a:t>
+              <a:t>16.09.2026</a:t>
             </a:fld>
             <a:endParaRPr lang="ru-KZ"/>
           </a:p>
@@ -8682,7 +8682,7 @@
           <a:p>
             <a:fld id="{80D97446-0BC7-4A66-B662-A168F6AE78B0}" type="datetimeFigureOut">
               <a:rPr lang="ru-KZ" smtClean="0"/>
-              <a:t>15.09.2026</a:t>
+              <a:t>16.09.2026</a:t>
             </a:fld>
             <a:endParaRPr lang="ru-KZ"/>
           </a:p>
@@ -9101,7 +9101,7 @@
           <a:p>
             <a:fld id="{80D97446-0BC7-4A66-B662-A168F6AE78B0}" type="datetimeFigureOut">
               <a:rPr lang="ru-KZ" smtClean="0"/>
-              <a:t>15.09.2026</a:t>
+              <a:t>16.09.2026</a:t>
             </a:fld>
             <a:endParaRPr lang="ru-KZ"/>
           </a:p>
@@ -9506,7 +9506,7 @@
           <a:p>
             <a:fld id="{80D97446-0BC7-4A66-B662-A168F6AE78B0}" type="datetimeFigureOut">
               <a:rPr lang="ru-KZ" smtClean="0"/>
-              <a:t>15.09.2026</a:t>
+              <a:t>16.09.2026</a:t>
             </a:fld>
             <a:endParaRPr lang="ru-KZ"/>
           </a:p>
@@ -9793,7 +9793,7 @@
           <a:p>
             <a:fld id="{80D97446-0BC7-4A66-B662-A168F6AE78B0}" type="datetimeFigureOut">
               <a:rPr lang="ru-KZ" smtClean="0"/>
-              <a:t>15.09.2026</a:t>
+              <a:t>16.09.2026</a:t>
             </a:fld>
             <a:endParaRPr lang="ru-KZ"/>
           </a:p>
@@ -10303,7 +10303,7 @@
           <a:p>
             <a:fld id="{80D97446-0BC7-4A66-B662-A168F6AE78B0}" type="datetimeFigureOut">
               <a:rPr lang="ru-KZ" smtClean="0"/>
-              <a:t>15.09.2026</a:t>
+              <a:t>16.09.2026</a:t>
             </a:fld>
             <a:endParaRPr lang="ru-KZ"/>
           </a:p>
@@ -10720,7 +10720,7 @@
           <a:p>
             <a:fld id="{80D97446-0BC7-4A66-B662-A168F6AE78B0}" type="datetimeFigureOut">
               <a:rPr lang="ru-KZ" smtClean="0"/>
-              <a:t>15.09.2026</a:t>
+              <a:t>16.09.2026</a:t>
             </a:fld>
             <a:endParaRPr lang="ru-KZ"/>
           </a:p>
@@ -11029,7 +11029,7 @@
           <a:p>
             <a:fld id="{80D97446-0BC7-4A66-B662-A168F6AE78B0}" type="datetimeFigureOut">
               <a:rPr lang="ru-KZ" smtClean="0"/>
-              <a:t>15.09.2026</a:t>
+              <a:t>16.09.2026</a:t>
             </a:fld>
             <a:endParaRPr lang="ru-KZ"/>
           </a:p>
@@ -11392,7 +11392,7 @@
           <a:p>
             <a:fld id="{80D97446-0BC7-4A66-B662-A168F6AE78B0}" type="datetimeFigureOut">
               <a:rPr lang="ru-KZ" smtClean="0"/>
-              <a:t>15.09.2026</a:t>
+              <a:t>16.09.2026</a:t>
             </a:fld>
             <a:endParaRPr lang="ru-KZ"/>
           </a:p>
@@ -11765,7 +11765,7 @@
           <a:p>
             <a:fld id="{80D97446-0BC7-4A66-B662-A168F6AE78B0}" type="datetimeFigureOut">
               <a:rPr lang="ru-KZ" smtClean="0"/>
-              <a:t>15.09.2026</a:t>
+              <a:t>16.09.2026</a:t>
             </a:fld>
             <a:endParaRPr lang="ru-KZ"/>
           </a:p>
@@ -12571,7 +12571,12 @@
             <p:ph idx="1"/>
           </p:nvPr>
         </p:nvSpPr>
-        <p:spPr/>
+        <p:spPr>
+          <a:xfrm>
+            <a:off x="533397" y="2129476"/>
+            <a:ext cx="11125202" cy="4728524"/>
+          </a:xfrm>
+        </p:spPr>
         <p:txBody>
           <a:bodyPr>
             <a:normAutofit/>
@@ -12822,10 +12827,10 @@
       </p:sp>
       <p:pic>
         <p:nvPicPr>
-          <p:cNvPr id="9" name="Picture 8">
-            <a:extLst>
-              <a:ext uri="{FF2B5EF4-FFF2-40B4-BE49-F238E27FC236}">
-                <a16:creationId xmlns:a16="http://schemas.microsoft.com/office/drawing/2014/main" id="{1E5293A1-4959-25AC-D404-58C20344E499}"/>
+          <p:cNvPr id="3" name="Picture 2">
+            <a:extLst>
+              <a:ext uri="{FF2B5EF4-FFF2-40B4-BE49-F238E27FC236}">
+                <a16:creationId xmlns:a16="http://schemas.microsoft.com/office/drawing/2014/main" id="{28294D47-754C-E7B7-F19E-4D8837A9BA01}"/>
               </a:ext>
             </a:extLst>
           </p:cNvPr>
@@ -12835,24 +12840,25 @@
           <p:nvPr/>
         </p:nvPicPr>
         <p:blipFill>
-          <a:blip r:embed="rId2"/>
+          <a:blip r:embed="rId2">
+            <a:extLst>
+              <a:ext uri="{28A0092B-C50C-407E-A947-70E740481C1C}">
+                <a14:useLocalDpi xmlns:a14="http://schemas.microsoft.com/office/drawing/2010/main" val="0"/>
+              </a:ext>
+            </a:extLst>
+          </a:blip>
           <a:stretch>
             <a:fillRect/>
           </a:stretch>
         </p:blipFill>
         <p:spPr>
           <a:xfrm>
-            <a:off x="1137920" y="1621954"/>
+            <a:off x="1177250" y="1621953"/>
             <a:ext cx="8958580" cy="5024312"/>
           </a:xfrm>
           <a:prstGeom prst="rect">
             <a:avLst/>
           </a:prstGeom>
-          <a:ln w="19050">
-            <a:solidFill>
-              <a:srgbClr val="B0B0B0"/>
-            </a:solidFill>
-          </a:ln>
         </p:spPr>
       </p:pic>
     </p:spTree>
@@ -14067,45 +14073,6 @@
           </a:p>
         </p:txBody>
       </p:sp>
-      <p:sp>
-        <p:nvSpPr>
-          <p:cNvPr id="8" name="TextBox 7">
-            <a:extLst>
-              <a:ext uri="{FF2B5EF4-FFF2-40B4-BE49-F238E27FC236}">
-                <a16:creationId xmlns:a16="http://schemas.microsoft.com/office/drawing/2014/main" id="{0C0475DA-5FE3-1D58-7373-7855C4AD4131}"/>
-              </a:ext>
-            </a:extLst>
-          </p:cNvPr>
-          <p:cNvSpPr txBox="1"/>
-          <p:nvPr/>
-        </p:nvSpPr>
-        <p:spPr>
-          <a:xfrm>
-            <a:off x="495299" y="5986501"/>
-            <a:ext cx="11201400" cy="369332"/>
-          </a:xfrm>
-          <a:prstGeom prst="rect">
-            <a:avLst/>
-          </a:prstGeom>
-          <a:noFill/>
-          <a:ln>
-            <a:noFill/>
-          </a:ln>
-        </p:spPr>
-        <p:txBody>
-          <a:bodyPr vertOverflow="overflow" vert="horz" wrap="square" rtlCol="0" anchor="t">
-            <a:spAutoFit/>
-          </a:bodyPr>
-          <a:lstStyle/>
-          <a:p>
-            <a:r>
-              <a:rPr lang="en-US" dirty="0"/>
-              <a:t>Discontinuation is the alternative for these products</a:t>
-            </a:r>
-            <a:endParaRPr lang="ru-KZ" dirty="0"/>
-          </a:p>
-        </p:txBody>
-      </p:sp>
     </p:spTree>
     <p:extLst>
       <p:ext uri="{BB962C8B-B14F-4D97-AF65-F5344CB8AC3E}">
@@ -14152,13 +14119,19 @@
             <p:ph type="title"/>
           </p:nvPr>
         </p:nvSpPr>
-        <p:spPr/>
+        <p:spPr>
+          <a:xfrm>
+            <a:off x="533399" y="3055620"/>
+            <a:ext cx="11125201" cy="746759"/>
+          </a:xfrm>
+        </p:spPr>
         <p:txBody>
           <a:bodyPr>
             <a:normAutofit fontScale="90000"/>
           </a:bodyPr>
           <a:lstStyle/>
           <a:p>
+            <a:pPr algn="ctr"/>
             <a:r>
               <a:rPr lang="en-US" dirty="0"/>
               <a:t>Thank you for your attention</a:t>
@@ -14167,31 +14140,6 @@
               <a:rPr lang="en-US" dirty="0"/>
             </a:br>
             <a:endParaRPr lang="ru-KZ" dirty="0"/>
-          </a:p>
-        </p:txBody>
-      </p:sp>
-      <p:sp>
-        <p:nvSpPr>
-          <p:cNvPr id="3" name="Content Placeholder 2">
-            <a:extLst>
-              <a:ext uri="{FF2B5EF4-FFF2-40B4-BE49-F238E27FC236}">
-                <a16:creationId xmlns:a16="http://schemas.microsoft.com/office/drawing/2014/main" id="{7C9DFC03-9488-547F-4E42-0F838A0831FD}"/>
-              </a:ext>
-            </a:extLst>
-          </p:cNvPr>
-          <p:cNvSpPr>
-            <a:spLocks noGrp="1"/>
-          </p:cNvSpPr>
-          <p:nvPr>
-            <p:ph idx="1"/>
-          </p:nvPr>
-        </p:nvSpPr>
-        <p:spPr/>
-        <p:txBody>
-          <a:bodyPr/>
-          <a:lstStyle/>
-          <a:p>
-            <a:endParaRPr lang="ru-KZ"/>
           </a:p>
         </p:txBody>
       </p:sp>

</xml_diff>